<commit_message>
feat: closing-slide QR codes point at teachingthatlands.uk; footer link fixed
New QR on the three session decks (Adrian), one-day decks rebuilt. The
slide 1 footer link still targeted the old GitHub address even though the
visible text had changed: now set through the hyperlink itself.

Co-Authored-By: Claude Sonnet 5.5 <noreply@anthropic.com>
</commit_message>
<xml_diff>
--- a/site/public/slides/ttl-day1-death-by-powerpoint.pptx
+++ b/site/public/slides/ttl-day1-death-by-powerpoint.pptx
@@ -1619,137 +1619,69 @@
       </p:grpSpPr>
       <p:sp>
         <p:nvSpPr>
-          <p:cNvPr id="2" name="Slide Image Placeholder 1"/>
-          <p:cNvSpPr>
-            <a:spLocks noGrp="1" noRot="1" noChangeAspect="1"/>
-          </p:cNvSpPr>
-          <p:nvPr>
-            <p:ph type="sldImg" idx="2"/>
-          </p:nvPr>
-        </p:nvSpPr>
-        <p:spPr/>
-      </p:sp>
-      <p:sp>
-        <p:nvSpPr>
-          <p:cNvPr id="3" name="Notes Placeholder 2"/>
+          <p:cNvPr id="2" name="Notes Placeholder"/>
           <p:cNvSpPr>
             <a:spLocks noGrp="1"/>
           </p:cNvSpPr>
           <p:nvPr>
-            <p:ph type="body" sz="quarter" idx="3"/>
+            <p:ph type="body" idx="1"/>
           </p:nvPr>
         </p:nvSpPr>
-        <p:spPr/>
+        <p:spPr>
+          <a:xfrm>
+            <a:off x="685800" y="4400550"/>
+            <a:ext cx="5486400" cy="3600450"/>
+          </a:xfrm>
+        </p:spPr>
         <p:txBody>
           <a:bodyPr/>
           <a:lstStyle/>
           <a:p>
             <a:r>
-              <a:rPr dirty="0"/>
               <a:t>TIMING</a:t>
             </a:r>
           </a:p>
           <a:p>
             <a:r>
-              <a:rPr dirty="0"/>
-              <a:t>  1:14–1:15 (1 min)</a:t>
-            </a:r>
-          </a:p>
-          <a:p>
-            <a:r>
-              <a:rPr dirty="0"/>
-              <a:t>BUILDS</a:t>
-            </a:r>
-          </a:p>
-          <a:p>
-            <a:r>
-              <a:rPr dirty="0"/>
-              <a:t>  1: ✓ the learner / ✗ your memory</a:t>
-            </a:r>
-          </a:p>
-          <a:p>
-            <a:r>
-              <a:rPr dirty="0"/>
+              <a:t>  1:12–1:14 (2 min)</a:t>
+            </a:r>
+          </a:p>
+          <a:p>
+            <a:r>
               <a:t>SAY</a:t>
             </a:r>
           </a:p>
           <a:p>
             <a:r>
-              <a:rPr dirty="0"/>
-              <a:t>  Same message. One image, one question, your voice.</a:t>
-            </a:r>
-          </a:p>
-          <a:p>
-            <a:r>
-              <a:rPr dirty="0"/>
-              <a:t>  The last slide was a security blanket: it was for me.</a:t>
-            </a:r>
-          </a:p>
-          <a:p>
-            <a:r>
-              <a:rPr dirty="0"/>
-              <a:t>ASK</a:t>
-            </a:r>
-          </a:p>
-          <a:p>
-            <a:r>
-              <a:rPr dirty="0"/>
-              <a:t>  (Think, don't answer.) Ever put everything on a slide so you wouldn't forget it?</a:t>
-            </a:r>
-          </a:p>
-          <a:p>
-            <a:r>
-              <a:rPr dirty="0"/>
+              <a:t>  READ EVERY WORD ALOUD, slowly, facing the screen. That's the experience.</a:t>
+            </a:r>
+          </a:p>
+          <a:p>
+            <a:r>
+              <a:t>  Don't comment. Click on.</a:t>
+            </a:r>
+          </a:p>
+          <a:p>
+            <a:r>
               <a:t>WHY</a:t>
             </a:r>
           </a:p>
           <a:p>
             <a:r>
-              <a:rPr dirty="0"/>
-              <a:t>  Constructive alignment at slide scale (Biggs): does it serve what the learner needs to do? → /theories/constructive-alignment</a:t>
-            </a:r>
-          </a:p>
-          <a:p>
-            <a:r>
-              <a:rPr dirty="0"/>
-              <a:t>CREDITS</a:t>
-            </a:r>
-          </a:p>
-          <a:p>
-            <a:r>
-              <a:rPr dirty="0"/>
-              <a:t>  'It's my blanket!', </a:t>
-            </a:r>
-            <a:r>
-              <a:rPr dirty="0" err="1"/>
-              <a:t>Elecé</a:t>
-            </a:r>
-            <a:r>
-              <a:rPr dirty="0"/>
-              <a:t>, CC BY 2.0, https://</a:t>
-            </a:r>
-            <a:r>
-              <a:rPr dirty="0" err="1"/>
-              <a:t>www.flickr.com</a:t>
-            </a:r>
-            <a:r>
-              <a:rPr dirty="0"/>
-              <a:t>/photos/11498085@N00/5648654531</a:t>
-            </a:r>
-          </a:p>
-        </p:txBody>
-      </p:sp>
-      <p:sp>
-        <p:nvSpPr>
-          <p:cNvPr id="4" name="Slide Number Placeholder 3"/>
-          <p:cNvSpPr>
-            <a:spLocks noGrp="1"/>
-          </p:cNvSpPr>
-          <p:nvPr>
-            <p:ph type="sldNum" sz="quarter" idx="5"/>
-          </p:nvPr>
-        </p:nvSpPr>
-        <p:spPr/>
+              <a:t>  They feel what it's like when the slide is the presenter's script: two channels competing, and nobody looking at them.</a:t>
+            </a:r>
+          </a:p>
+          <a:p>
+            <a:r>
+              <a:t>IF SHORT</a:t>
+            </a:r>
+          </a:p>
+          <a:p>
+            <a:r>
+              <a:t>  Read the first four bullets only, then click on.</a:t>
+            </a:r>
+          </a:p>
+        </p:txBody>
       </p:sp>
     </p:spTree>
   </p:cSld>
@@ -1811,7 +1743,7 @@
           <a:p>
             <a:r>
               <a:rPr dirty="0"/>
-              <a:t>  1:15–1:17 (2 min)</a:t>
+              <a:t>  1:14–1:15 (1 min)</a:t>
             </a:r>
           </a:p>
           <a:p>
@@ -1823,7 +1755,7 @@
           <a:p>
             <a:r>
               <a:rPr dirty="0"/>
-              <a:t>  Morph in from the previous slide · 1: 'The detail didn't disappear…'</a:t>
+              <a:t>  1: ✓ the learner / ✗ your memory</a:t>
             </a:r>
           </a:p>
           <a:p>
@@ -1835,73 +1767,37 @@
           <a:p>
             <a:r>
               <a:rPr dirty="0"/>
-              <a:t>  So where did all that text go?</a:t>
-            </a:r>
-          </a:p>
-          <a:p>
-            <a:r>
-              <a:rPr dirty="0"/>
-              <a:t>  Into the notes: the one place that IS for you.</a:t>
-            </a:r>
-            <a:endParaRPr lang="en-GB" dirty="0"/>
-          </a:p>
-          <a:p>
-            <a:r>
-              <a:rPr lang="en-GB" dirty="0"/>
-              <a:t>  </a:t>
-            </a:r>
-            <a:r>
-              <a:rPr dirty="0"/>
-              <a:t>You can't decide what goes on the slide until you know what learners need to do. That's Day 3.</a:t>
-            </a:r>
-            <a:endParaRPr lang="en-GB" dirty="0"/>
-          </a:p>
-          <a:p>
-            <a:r>
-              <a:rPr lang="en-GB" dirty="0"/>
-              <a:t>  Also, notice the difference – 9 bullet points to a guided tour, one chunk at a time </a:t>
-            </a:r>
-            <a:r>
-              <a:rPr lang="en-GB" b="1" dirty="0"/>
-              <a:t>= scaffolding for the learner.</a:t>
-            </a:r>
-            <a:endParaRPr b="1" dirty="0"/>
+              <a:t>  Same message. One image, one question, your voice.</a:t>
+            </a:r>
+          </a:p>
+          <a:p>
+            <a:r>
+              <a:rPr dirty="0"/>
+              <a:t>  The last slide was a security blanket: it was for me.</a:t>
+            </a:r>
+          </a:p>
+          <a:p>
+            <a:r>
+              <a:rPr dirty="0"/>
+              <a:t>ASK</a:t>
+            </a:r>
+          </a:p>
+          <a:p>
+            <a:r>
+              <a:rPr dirty="0"/>
+              <a:t>  (Think, don't answer.) Ever put everything on a slide so you wouldn't forget it?</a:t>
+            </a:r>
           </a:p>
           <a:p>
             <a:r>
               <a:rPr dirty="0"/>
               <a:t>WHY</a:t>
             </a:r>
-            <a:endParaRPr lang="en-GB" dirty="0"/>
-          </a:p>
-          <a:p>
-            <a:r>
-              <a:rPr lang="en-GB" dirty="0"/>
-              <a:t>  Moves the security blanket to the presenter's notes rather than banning it; links the spine to Day 3. </a:t>
-            </a:r>
-            <a:endParaRPr lang="en-GB" b="0" dirty="0"/>
-          </a:p>
-          <a:p>
-            <a:r>
-              <a:rPr lang="en-GB" b="0" dirty="0"/>
-              <a:t>  </a:t>
-            </a:r>
-            <a:r>
-              <a:rPr lang="en-GB" dirty="0"/>
-              <a:t>Scaffolding (Wood, Bruner &amp; Ross, 1976) and segmenting (Mayer). It manages the topic's own difficulty, not just the clutter. → /theories/zone-of-proximal-development</a:t>
-            </a:r>
-            <a:endParaRPr dirty="0"/>
-          </a:p>
-          <a:p>
-            <a:r>
-              <a:rPr dirty="0"/>
-              <a:t>IF SHORT</a:t>
-            </a:r>
-          </a:p>
-          <a:p>
-            <a:r>
-              <a:rPr dirty="0"/>
-              <a:t>  Never cut this slide: it's the payoff of the previous two.</a:t>
+          </a:p>
+          <a:p>
+            <a:r>
+              <a:rPr dirty="0"/>
+              <a:t>  Constructive alignment at slide scale (Biggs): does it serve what the learner needs to do? → /theories/constructive-alignment</a:t>
             </a:r>
           </a:p>
           <a:p>
@@ -2149,7 +2045,19 @@
           <a:p>
             <a:r>
               <a:rPr dirty="0"/>
-              <a:t>  1:17–1:19 (2 min)</a:t>
+              <a:t>  1:15–1:17 (2 min)</a:t>
+            </a:r>
+          </a:p>
+          <a:p>
+            <a:r>
+              <a:rPr dirty="0"/>
+              <a:t>BUILDS</a:t>
+            </a:r>
+          </a:p>
+          <a:p>
+            <a:r>
+              <a:rPr dirty="0"/>
+              <a:t>  Morph in from the previous slide · 1: 'The detail didn't disappear…'</a:t>
             </a:r>
           </a:p>
           <a:p>
@@ -2161,8 +2069,62 @@
           <a:p>
             <a:r>
               <a:rPr dirty="0"/>
-              <a:t>  Hold that thought for next week.</a:t>
-            </a:r>
+              <a:t>  So where did all that text go?</a:t>
+            </a:r>
+          </a:p>
+          <a:p>
+            <a:r>
+              <a:rPr dirty="0"/>
+              <a:t>  Into the notes: the one place that IS for you.</a:t>
+            </a:r>
+            <a:endParaRPr lang="en-GB" dirty="0"/>
+          </a:p>
+          <a:p>
+            <a:r>
+              <a:rPr lang="en-GB" dirty="0"/>
+              <a:t>  </a:t>
+            </a:r>
+            <a:r>
+              <a:rPr dirty="0"/>
+              <a:t>You can't decide what goes on the slide until you know what learners need to do. That's Day 3.</a:t>
+            </a:r>
+            <a:endParaRPr lang="en-GB" dirty="0"/>
+          </a:p>
+          <a:p>
+            <a:r>
+              <a:rPr lang="en-GB" dirty="0"/>
+              <a:t>  Also, notice the difference – 9 bullet points to a guided tour, one chunk at a time </a:t>
+            </a:r>
+            <a:r>
+              <a:rPr lang="en-GB" b="1" dirty="0"/>
+              <a:t>= scaffolding for the learner.</a:t>
+            </a:r>
+            <a:endParaRPr b="1" dirty="0"/>
+          </a:p>
+          <a:p>
+            <a:r>
+              <a:rPr dirty="0"/>
+              <a:t>WHY</a:t>
+            </a:r>
+            <a:endParaRPr lang="en-GB" dirty="0"/>
+          </a:p>
+          <a:p>
+            <a:r>
+              <a:rPr lang="en-GB" dirty="0"/>
+              <a:t>  Moves the security blanket to the presenter's notes rather than banning it; links the spine to Day 3. </a:t>
+            </a:r>
+            <a:endParaRPr lang="en-GB" b="0" dirty="0"/>
+          </a:p>
+          <a:p>
+            <a:r>
+              <a:rPr lang="en-GB" b="0" dirty="0"/>
+              <a:t>  </a:t>
+            </a:r>
+            <a:r>
+              <a:rPr lang="en-GB" dirty="0"/>
+              <a:t>Scaffolding (Wood, Bruner &amp; Ross, 1976) and segmenting (Mayer). It manages the topic's own difficulty, not just the clutter. → /theories/zone-of-proximal-development</a:t>
+            </a:r>
+            <a:endParaRPr dirty="0"/>
           </a:p>
           <a:p>
             <a:r>
@@ -2173,7 +2135,35 @@
           <a:p>
             <a:r>
               <a:rPr dirty="0"/>
-              <a:t>  Never cut (it's 10 seconds).</a:t>
+              <a:t>  Never cut this slide: it's the payoff of the previous two.</a:t>
+            </a:r>
+          </a:p>
+          <a:p>
+            <a:r>
+              <a:rPr dirty="0"/>
+              <a:t>CREDITS</a:t>
+            </a:r>
+          </a:p>
+          <a:p>
+            <a:r>
+              <a:rPr dirty="0"/>
+              <a:t>  'It's my blanket!', </a:t>
+            </a:r>
+            <a:r>
+              <a:rPr dirty="0" err="1"/>
+              <a:t>Elecé</a:t>
+            </a:r>
+            <a:r>
+              <a:rPr dirty="0"/>
+              <a:t>, CC BY 2.0, https://</a:t>
+            </a:r>
+            <a:r>
+              <a:rPr dirty="0" err="1"/>
+              <a:t>www.flickr.com</a:t>
+            </a:r>
+            <a:r>
+              <a:rPr dirty="0"/>
+              <a:t>/photos/11498085@N00/5648654531</a:t>
             </a:r>
           </a:p>
         </p:txBody>
@@ -2250,7 +2240,7 @@
           <a:p>
             <a:r>
               <a:rPr dirty="0"/>
-              <a:t>  1:19–1:26 (7 min)</a:t>
+              <a:t>  1:17–1:19 (2 min)</a:t>
             </a:r>
           </a:p>
           <a:p>
@@ -2262,31 +2252,7 @@
           <a:p>
             <a:r>
               <a:rPr dirty="0"/>
-              <a:t>  Write it on the card NOW, in the room. Add WHICH slides or WHERE you'll look. Photograph it.</a:t>
-            </a:r>
-          </a:p>
-          <a:p>
-            <a:r>
-              <a:rPr dirty="0"/>
-              <a:t>  No slides of your own? The ask is to FIND one (intranet, a lecture, a training day) and fix it.</a:t>
-            </a:r>
-          </a:p>
-          <a:p>
-            <a:r>
-              <a:rPr dirty="0"/>
-              <a:t>  We start next week by looking at what you did.</a:t>
-            </a:r>
-          </a:p>
-          <a:p>
-            <a:r>
-              <a:rPr dirty="0"/>
-              <a:t>WHY</a:t>
-            </a:r>
-          </a:p>
-          <a:p>
-            <a:r>
-              <a:rPr dirty="0"/>
-              <a:t>  A specific written intention plus a follow-up loop (implementation intentions). The follow-up is next week's opener. → /theories/implementation-intentions</a:t>
+              <a:t>  Hold that thought for next week.</a:t>
             </a:r>
           </a:p>
           <a:p>
@@ -2298,7 +2264,7 @@
           <a:p>
             <a:r>
               <a:rPr dirty="0"/>
-              <a:t>  NEVER CUT. Start at 1:20 even mid-discussion.</a:t>
+              <a:t>  Never cut (it's 10 seconds).</a:t>
             </a:r>
           </a:p>
         </p:txBody>
@@ -2375,7 +2341,7 @@
           <a:p>
             <a:r>
               <a:rPr dirty="0"/>
-              <a:t>  1:26–1:30 (close + buffer)</a:t>
+              <a:t>  1:19–1:26 (7 min)</a:t>
             </a:r>
           </a:p>
           <a:p>
@@ -2387,16 +2353,44 @@
           <a:p>
             <a:r>
               <a:rPr dirty="0"/>
-              <a:t>  Thank you. Next week starts with your slides.</a:t>
-            </a:r>
-            <a:endParaRPr lang="en-GB" dirty="0"/>
-          </a:p>
-          <a:p>
-            <a:r>
-              <a:rPr lang="en-GB" dirty="0"/>
-              <a:t>  QR Code goes to website</a:t>
-            </a:r>
-            <a:endParaRPr dirty="0"/>
+              <a:t>  Write it on the card NOW, in the room. Add WHICH slides or WHERE you'll look. Photograph it.</a:t>
+            </a:r>
+          </a:p>
+          <a:p>
+            <a:r>
+              <a:rPr dirty="0"/>
+              <a:t>  No slides of your own? The ask is to FIND one (intranet, a lecture, a training day) and fix it.</a:t>
+            </a:r>
+          </a:p>
+          <a:p>
+            <a:r>
+              <a:rPr dirty="0"/>
+              <a:t>  We start next week by looking at what you did.</a:t>
+            </a:r>
+          </a:p>
+          <a:p>
+            <a:r>
+              <a:rPr dirty="0"/>
+              <a:t>WHY</a:t>
+            </a:r>
+          </a:p>
+          <a:p>
+            <a:r>
+              <a:rPr dirty="0"/>
+              <a:t>  A specific written intention plus a follow-up loop (implementation intentions). The follow-up is next week's opener. → /theories/implementation-intentions</a:t>
+            </a:r>
+          </a:p>
+          <a:p>
+            <a:r>
+              <a:rPr dirty="0"/>
+              <a:t>IF SHORT</a:t>
+            </a:r>
+          </a:p>
+          <a:p>
+            <a:r>
+              <a:rPr dirty="0"/>
+              <a:t>  NEVER CUT. Start at 1:20 even mid-discussion.</a:t>
+            </a:r>
           </a:p>
         </p:txBody>
       </p:sp>
@@ -2465,13 +2459,35 @@
           <a:lstStyle/>
           <a:p>
             <a:r>
+              <a:rPr dirty="0"/>
+              <a:t>TIMING</a:t>
+            </a:r>
+          </a:p>
+          <a:p>
+            <a:r>
+              <a:rPr dirty="0"/>
+              <a:t>  1:26–1:30 (close + buffer)</a:t>
+            </a:r>
+          </a:p>
+          <a:p>
+            <a:r>
+              <a:rPr dirty="0"/>
               <a:t>SAY</a:t>
             </a:r>
           </a:p>
           <a:p>
             <a:r>
-              <a:t>  Not presented. Here for licence compliance and for anyone adapting the deck.</a:t>
-            </a:r>
+              <a:rPr dirty="0"/>
+              <a:t>  Thank you. Next week starts with your slides.</a:t>
+            </a:r>
+            <a:endParaRPr lang="en-GB" dirty="0"/>
+          </a:p>
+          <a:p>
+            <a:r>
+              <a:rPr lang="en-GB" dirty="0"/>
+              <a:t>  QR Code goes to website</a:t>
+            </a:r>
+            <a:endParaRPr dirty="0"/>
           </a:p>
         </p:txBody>
       </p:sp>
@@ -2496,7 +2512,7 @@
 </file>
 
 <file path=ppt/notesSlides/notesSlide24.xml><?xml version="1.0" encoding="utf-8"?>
-<p:notes xmlns:a="http://schemas.openxmlformats.org/drawingml/2006/main" xmlns:p="http://schemas.openxmlformats.org/presentationml/2006/main" xmlns:r="http://schemas.openxmlformats.org/officeDocument/2006/relationships">
+<p:notes xmlns:a="http://schemas.openxmlformats.org/drawingml/2006/main" xmlns:r="http://schemas.openxmlformats.org/officeDocument/2006/relationships" xmlns:p="http://schemas.openxmlformats.org/presentationml/2006/main">
   <p:cSld>
     <p:spTree>
       <p:nvGrpSpPr>
@@ -2514,69 +2530,53 @@
       </p:grpSpPr>
       <p:sp>
         <p:nvSpPr>
-          <p:cNvPr id="2" name="Notes Placeholder"/>
+          <p:cNvPr id="2" name="Slide Image Placeholder 1"/>
+          <p:cNvSpPr>
+            <a:spLocks noGrp="1" noRot="1" noChangeAspect="1"/>
+          </p:cNvSpPr>
+          <p:nvPr>
+            <p:ph type="sldImg" idx="2"/>
+          </p:nvPr>
+        </p:nvSpPr>
+        <p:spPr/>
+      </p:sp>
+      <p:sp>
+        <p:nvSpPr>
+          <p:cNvPr id="3" name="Notes Placeholder 2"/>
           <p:cNvSpPr>
             <a:spLocks noGrp="1"/>
           </p:cNvSpPr>
           <p:nvPr>
-            <p:ph type="body" idx="1"/>
+            <p:ph type="body" sz="quarter" idx="3"/>
           </p:nvPr>
         </p:nvSpPr>
-        <p:spPr>
-          <a:xfrm>
-            <a:off x="685800" y="4400550"/>
-            <a:ext cx="5486400" cy="3600450"/>
-          </a:xfrm>
-        </p:spPr>
+        <p:spPr/>
         <p:txBody>
           <a:bodyPr/>
           <a:lstStyle/>
           <a:p>
             <a:r>
-              <a:t>TIMING</a:t>
-            </a:r>
-          </a:p>
-          <a:p>
-            <a:r>
-              <a:t>  1:12–1:14 (2 min)</a:t>
-            </a:r>
-          </a:p>
-          <a:p>
-            <a:r>
               <a:t>SAY</a:t>
             </a:r>
           </a:p>
           <a:p>
             <a:r>
-              <a:t>  READ EVERY WORD ALOUD, slowly, facing the screen. That's the experience.</a:t>
-            </a:r>
-          </a:p>
-          <a:p>
-            <a:r>
-              <a:t>  Don't comment. Click on.</a:t>
-            </a:r>
-          </a:p>
-          <a:p>
-            <a:r>
-              <a:t>WHY</a:t>
-            </a:r>
-          </a:p>
-          <a:p>
-            <a:r>
-              <a:t>  They feel what it's like when the slide is the presenter's script: two channels competing, and nobody looking at them.</a:t>
-            </a:r>
-          </a:p>
-          <a:p>
-            <a:r>
-              <a:t>IF SHORT</a:t>
-            </a:r>
-          </a:p>
-          <a:p>
-            <a:r>
-              <a:t>  Read the first four bullets only, then click on.</a:t>
-            </a:r>
-          </a:p>
-        </p:txBody>
+              <a:t>  Not presented. Here for licence compliance and for anyone adapting the deck.</a:t>
+            </a:r>
+          </a:p>
+        </p:txBody>
+      </p:sp>
+      <p:sp>
+        <p:nvSpPr>
+          <p:cNvPr id="4" name="Slide Number Placeholder 3"/>
+          <p:cNvSpPr>
+            <a:spLocks noGrp="1"/>
+          </p:cNvSpPr>
+          <p:nvPr>
+            <p:ph type="sldNum" sz="quarter" idx="5"/>
+          </p:nvPr>
+        </p:nvSpPr>
+        <p:spPr/>
       </p:sp>
     </p:spTree>
   </p:cSld>
@@ -3549,7 +3549,7 @@
           <a:p>
             <a:fld id="{5BCAD085-E8A6-8845-BD4E-CB4CCA059FC4}" type="datetimeFigureOut">
               <a:rPr lang="en-US" smtClean="0"/>
-              <a:t>10/2/26</a:t>
+              <a:t>10/6/26</a:t>
             </a:fld>
             <a:endParaRPr lang="en-US"/>
           </a:p>
@@ -3717,7 +3717,7 @@
           <a:p>
             <a:fld id="{5BCAD085-E8A6-8845-BD4E-CB4CCA059FC4}" type="datetimeFigureOut">
               <a:rPr lang="en-US" smtClean="0"/>
-              <a:t>10/2/26</a:t>
+              <a:t>10/6/26</a:t>
             </a:fld>
             <a:endParaRPr lang="en-US"/>
           </a:p>
@@ -3895,7 +3895,7 @@
           <a:p>
             <a:fld id="{5BCAD085-E8A6-8845-BD4E-CB4CCA059FC4}" type="datetimeFigureOut">
               <a:rPr lang="en-US" smtClean="0"/>
-              <a:t>10/2/26</a:t>
+              <a:t>10/6/26</a:t>
             </a:fld>
             <a:endParaRPr lang="en-US"/>
           </a:p>
@@ -4063,7 +4063,7 @@
           <a:p>
             <a:fld id="{5BCAD085-E8A6-8845-BD4E-CB4CCA059FC4}" type="datetimeFigureOut">
               <a:rPr lang="en-US" smtClean="0"/>
-              <a:t>10/2/26</a:t>
+              <a:t>10/6/26</a:t>
             </a:fld>
             <a:endParaRPr lang="en-US"/>
           </a:p>
@@ -4308,7 +4308,7 @@
           <a:p>
             <a:fld id="{5BCAD085-E8A6-8845-BD4E-CB4CCA059FC4}" type="datetimeFigureOut">
               <a:rPr lang="en-US" smtClean="0"/>
-              <a:t>10/2/26</a:t>
+              <a:t>10/6/26</a:t>
             </a:fld>
             <a:endParaRPr lang="en-US"/>
           </a:p>
@@ -4593,7 +4593,7 @@
           <a:p>
             <a:fld id="{5BCAD085-E8A6-8845-BD4E-CB4CCA059FC4}" type="datetimeFigureOut">
               <a:rPr lang="en-US" smtClean="0"/>
-              <a:t>10/2/26</a:t>
+              <a:t>10/6/26</a:t>
             </a:fld>
             <a:endParaRPr lang="en-US"/>
           </a:p>
@@ -5012,7 +5012,7 @@
           <a:p>
             <a:fld id="{5BCAD085-E8A6-8845-BD4E-CB4CCA059FC4}" type="datetimeFigureOut">
               <a:rPr lang="en-US" smtClean="0"/>
-              <a:t>10/2/26</a:t>
+              <a:t>10/6/26</a:t>
             </a:fld>
             <a:endParaRPr lang="en-US"/>
           </a:p>
@@ -5129,7 +5129,7 @@
           <a:p>
             <a:fld id="{5BCAD085-E8A6-8845-BD4E-CB4CCA059FC4}" type="datetimeFigureOut">
               <a:rPr lang="en-US" smtClean="0"/>
-              <a:t>10/2/26</a:t>
+              <a:t>10/6/26</a:t>
             </a:fld>
             <a:endParaRPr lang="en-US"/>
           </a:p>
@@ -5224,7 +5224,7 @@
           <a:p>
             <a:fld id="{5BCAD085-E8A6-8845-BD4E-CB4CCA059FC4}" type="datetimeFigureOut">
               <a:rPr lang="en-US" smtClean="0"/>
-              <a:t>10/2/26</a:t>
+              <a:t>10/6/26</a:t>
             </a:fld>
             <a:endParaRPr lang="en-US"/>
           </a:p>
@@ -5499,7 +5499,7 @@
           <a:p>
             <a:fld id="{5BCAD085-E8A6-8845-BD4E-CB4CCA059FC4}" type="datetimeFigureOut">
               <a:rPr lang="en-US" smtClean="0"/>
-              <a:t>10/2/26</a:t>
+              <a:t>10/6/26</a:t>
             </a:fld>
             <a:endParaRPr lang="en-US"/>
           </a:p>
@@ -5751,7 +5751,7 @@
           <a:p>
             <a:fld id="{5BCAD085-E8A6-8845-BD4E-CB4CCA059FC4}" type="datetimeFigureOut">
               <a:rPr lang="en-US" smtClean="0"/>
-              <a:t>10/2/26</a:t>
+              <a:t>10/6/26</a:t>
             </a:fld>
             <a:endParaRPr lang="en-US"/>
           </a:p>
@@ -5962,7 +5962,7 @@
           <a:p>
             <a:fld id="{5BCAD085-E8A6-8845-BD4E-CB4CCA059FC4}" type="datetimeFigureOut">
               <a:rPr lang="en-US" smtClean="0"/>
-              <a:t>10/2/26</a:t>
+              <a:t>10/6/26</a:t>
             </a:fld>
             <a:endParaRPr lang="en-US"/>
           </a:p>
@@ -6512,13 +6512,7 @@
                   <a:srgbClr val="B24200"/>
                 </a:solidFill>
                 <a:latin typeface="Aptos"/>
-                <a:hlinkClick r:id="rId4">
-                  <a:extLst>
-                    <a:ext uri="{A12FA001-AC4F-418D-AE19-62706E023703}">
-                      <ahyp:hlinkClr xmlns:ahyp="http://schemas.microsoft.com/office/drawing/2018/hyperlinkcolor" val="tx"/>
-                    </a:ext>
-                  </a:extLst>
-                </a:hlinkClick>
+                <a:hlinkClick r:id="rId4"/>
               </a:rPr>
               <a:t>https://teachingthatlands.uk/</a:t>
             </a:r>
@@ -10064,33 +10058,6 @@
               </a:rPr>
               <a:t>Hold it up!</a:t>
             </a:r>
-            <a:r>
-              <a:rPr sz="2800" b="1" dirty="0">
-                <a:solidFill>
-                  <a:srgbClr val="4C4F69"/>
-                </a:solidFill>
-                <a:latin typeface="Aptos"/>
-              </a:rPr>
-              <a:t/>
-            </a:r>
-            <a:r>
-              <a:rPr lang="en-GB" sz="2800" b="1" dirty="0">
-                <a:solidFill>
-                  <a:srgbClr val="4C4F69"/>
-                </a:solidFill>
-                <a:latin typeface="Aptos"/>
-              </a:rPr>
-              <a:t/>
-            </a:r>
-            <a:r>
-              <a:rPr sz="2800" b="1" dirty="0">
-                <a:solidFill>
-                  <a:srgbClr val="4C4F69"/>
-                </a:solidFill>
-                <a:latin typeface="Aptos"/>
-              </a:rPr>
-              <a:t/>
-            </a:r>
           </a:p>
         </p:txBody>
       </p:sp>
@@ -10639,7 +10606,7 @@
           <p:nvPr/>
         </p:nvPicPr>
         <p:blipFill>
-          <a:blip r:embed="rId2" cstate="screen">
+          <a:blip r:embed="rId3" cstate="screen">
             <a:extLst>
               <a:ext uri="{28A0092B-C50C-407E-A947-70E740481C1C}">
                 <a14:useLocalDpi xmlns:a14="http://schemas.microsoft.com/office/drawing/2010/main"/>
@@ -13052,10 +13019,10 @@
       </p:sp>
       <p:pic>
         <p:nvPicPr>
-          <p:cNvPr id="7" name="Graphic 6">
+          <p:cNvPr id="5" name="Graphic 4">
             <a:extLst>
               <a:ext uri="{FF2B5EF4-FFF2-40B4-BE49-F238E27FC236}">
-                <a16:creationId xmlns:a16="http://schemas.microsoft.com/office/drawing/2014/main" id="{00FAF3DA-C001-AEED-1AE9-013A643EC345}"/>
+                <a16:creationId xmlns:a16="http://schemas.microsoft.com/office/drawing/2014/main" id="{5E40EAC8-DE1F-5623-DF43-855833FFA675}"/>
               </a:ext>
             </a:extLst>
           </p:cNvPr>
@@ -13078,7 +13045,7 @@
         </p:blipFill>
         <p:spPr>
           <a:xfrm>
-            <a:off x="3393936" y="1031333"/>
+            <a:off x="3418403" y="1031333"/>
             <a:ext cx="1969737" cy="1969737"/>
           </a:xfrm>
           <a:prstGeom prst="rect">
@@ -14738,7 +14705,7 @@
           <p:nvPr/>
         </p:nvPicPr>
         <p:blipFill>
-          <a:blip r:embed="rId4"/>
+          <a:blip r:embed="rId3"/>
           <a:stretch>
             <a:fillRect/>
           </a:stretch>

</xml_diff>

<commit_message>
Put the Redesign Worksheet through the programme
- Session guides: worksheet handed out in Session 1; four minutes on
  sections 1–3 after the Session 1 ask; section 4 in the last three
  minutes of Session 2's design block; Session 3's rewrite, "Does it line
  up?" and follow-through fill sections 5 and 6, and the commitment is the
  finished worksheet, photographed. One-day guide to match.
- Decks: Day 3 slides 10, 12, 13, 15 and 17 point to worksheet sections;
  notes updated on Days 1–3. One-day decks rebuilt.
- Participant pages, the rubric (now mapped to sections), Portfolio
  Mapping E3, and kit lists updated. The six-box canvas stays as the map
  and the Day 3 reveal.
- Worksheet tags now match the guides.

Co-Authored-By: Claude Opus 5.5 <noreply@anthropic.com>
Claude-Session: https://claude.ai/code/session_01XK6DruivtFd8CyZvsnEkSA
</commit_message>
<xml_diff>
--- a/site/public/slides/ttl-day1-death-by-powerpoint.pptx
+++ b/site/public/slides/ttl-day1-death-by-powerpoint.pptx
@@ -2341,7 +2341,7 @@
           <a:p>
             <a:r>
               <a:rPr dirty="0"/>
-              <a:t>  1:19–1:26 (7 min)</a:t>
+              <a:t>  1:19–1:24 (5 min)</a:t>
             </a:r>
           </a:p>
           <a:p>
@@ -2390,6 +2390,21 @@
             <a:r>
               <a:rPr dirty="0"/>
               <a:t>  NEVER CUT. Start at 1:20 even mid-discussion.</a:t>
+            </a:r>
+          </a:p>
+          <a:p>
+            <a:r>
+              <a:t>THEN (1:24–1:28)</a:t>
+            </a:r>
+          </a:p>
+          <a:p>
+            <a:r>
+              <a:t>  Worksheet, sections 1–3: their learners, the need, and the slide they redesigned. Writing it down is retrieval.</a:t>
+            </a:r>
+          </a:p>
+          <a:p>
+            <a:r>
+              <a:t>  IF SHORT: they finish it at home; it opens next week.</a:t>
             </a:r>
           </a:p>
         </p:txBody>
@@ -2826,6 +2841,16 @@
             <a:r>
               <a:rPr dirty="0"/>
               <a:t>  Never cut (it's the map).</a:t>
+            </a:r>
+          </a:p>
+          <a:p>
+            <a:r>
+              <a:t>FACILITATOR</a:t>
+            </a:r>
+          </a:p>
+          <a:p>
+            <a:r>
+              <a:t>  Hand out the Redesign Worksheet now, one each. The map at the top is this slide; they keep the sheet for all three weeks.</a:t>
             </a:r>
           </a:p>
         </p:txBody>

</xml_diff>